<commit_message>
Deck: tautan repositori di slide 13; catat status dashboard
Co-Authored-By: Claude Opus 5.5 <noreply@anthropic.com>
</commit_message>
<xml_diff>
--- a/docs/deck/PayRay_Healthkathon2026_revisi.pptx
+++ b/docs/deck/PayRay_Healthkathon2026_revisi.pptx
@@ -126,53 +126,53 @@
   <p:extLst>
     <p:ext uri="{521415D9-36F7-43E2-AB2F-B90AF26B5E84}">
       <p14:sectionLst xmlns:p14="http://schemas.microsoft.com/office/powerpoint/2010/main">
-        <p14:section name="Pembuka" id="{94102b2e-79a9-0b3e-ee97-686f572d4ad2}">
+        <p14:section name="Pembuka" id="{01a9ce37-3fdd-c44d-9d52-c11413e65967}">
           <p14:sldIdLst>
             <p14:sldId id="256"/>
             <p14:sldId id="257"/>
           </p14:sldIdLst>
         </p14:section>
-        <p14:section name="Masalah" id="{9680cb9b-ee35-92ae-b111-fef1aa1598f2}">
+        <p14:section name="Masalah" id="{0817fac1-8dff-eaa2-a647-2cfda0e5a362}">
           <p14:sldIdLst>
             <p14:sldId id="258"/>
             <p14:sldId id="259"/>
           </p14:sldIdLst>
         </p14:section>
-        <p14:section name="Solusi" id="{829b1b3c-1ab8-b216-364f-204e48df63e2}">
+        <p14:section name="Solusi" id="{a8fed365-2822-87d1-cd1a-521626ca29e5}">
           <p14:sldIdLst>
             <p14:sldId id="260"/>
             <p14:sldId id="261"/>
             <p14:sldId id="262"/>
           </p14:sldIdLst>
         </p14:section>
-        <p14:section name="Teknis &amp; data" id="{692893a6-af8c-23b9-10ff-c6137a66acd9}">
+        <p14:section name="Teknis &amp; data" id="{6fd79dfb-5d64-97fa-1d5d-6b1682e7d759}">
           <p14:sldIdLst>
             <p14:sldId id="263"/>
             <p14:sldId id="264"/>
             <p14:sldId id="265"/>
           </p14:sldIdLst>
         </p14:section>
-        <p14:section name="Hasil" id="{d694369f-abee-d948-bac3-9ca02abad5ea}">
+        <p14:section name="Hasil" id="{8f11c081-4802-636a-8cdb-cee0f64152eb}">
           <p14:sldIdLst>
             <p14:sldId id="266"/>
             <p14:sldId id="267"/>
             <p14:sldId id="268"/>
           </p14:sldIdLst>
         </p14:section>
-        <p14:section name="Rencana" id="{f4ddb6bc-b73b-c7c2-1543-143fb6265511}">
+        <p14:section name="Rencana" id="{266b0b75-e79f-0722-55dd-c922a0e355f7}">
           <p14:sldIdLst>
             <p14:sldId id="269"/>
             <p14:sldId id="270"/>
           </p14:sldIdLst>
         </p14:section>
-        <p14:section name="Dampak" id="{8c445ee7-901a-30db-61dc-bcd1af5c2c22}">
+        <p14:section name="Dampak" id="{abd87249-df72-7a6a-2138-fc6049af9460}">
           <p14:sldIdLst>
             <p14:sldId id="271"/>
             <p14:sldId id="272"/>
             <p14:sldId id="273"/>
           </p14:sldIdLst>
         </p14:section>
-        <p14:section name="Tim &amp; penutup" id="{68fc89b6-83ba-dca2-b925-1f488ce0c9dd}">
+        <p14:section name="Tim &amp; penutup" id="{64d5e1c4-1a28-4aef-e4af-e55ecfbe3cba}">
           <p14:sldIdLst>
             <p14:sldId id="274"/>
             <p14:sldId id="275"/>
@@ -8078,7 +8078,7 @@
                   <a:schemeClr val="tx1"/>
                 </a:solidFill>
               </a:rPr>
-              <a:t>Repositori: [__]</a:t>
+              <a:t>Repositori: github.com/rachdiaan/healthkathon-bpjs</a:t>
             </a:r>
             <a:endParaRPr lang="en-US" sz="1500" dirty="0"/>
           </a:p>

</xml_diff>

<commit_message>
Deck & dashboard: kembalikan istilah teknis ke bahasa Inggris
feedback loop, screenshot, ground truth, blind injection, holdout test,
tuning, label leakage, best single rule, random, easy/hard case.

Co-Authored-By: Claude Opus 5.5 <noreply@anthropic.com>
</commit_message>
<xml_diff>
--- a/docs/deck/PayRay_Healthkathon2026_revisi.pptx
+++ b/docs/deck/PayRay_Healthkathon2026_revisi.pptx
@@ -126,53 +126,53 @@
   <p:extLst>
     <p:ext uri="{521415D9-36F7-43E2-AB2F-B90AF26B5E84}">
       <p14:sectionLst xmlns:p14="http://schemas.microsoft.com/office/powerpoint/2010/main">
-        <p14:section name="Pembuka" id="{01a9ce37-3fdd-c44d-9d52-c11413e65967}">
+        <p14:section name="Pembuka" id="{c660a211-5ae8-4ee9-73b5-03485162d572}">
           <p14:sldIdLst>
             <p14:sldId id="256"/>
             <p14:sldId id="257"/>
           </p14:sldIdLst>
         </p14:section>
-        <p14:section name="Masalah" id="{0817fac1-8dff-eaa2-a647-2cfda0e5a362}">
+        <p14:section name="Masalah" id="{6ab41160-dcda-2423-b02b-2c3609aeeacb}">
           <p14:sldIdLst>
             <p14:sldId id="258"/>
             <p14:sldId id="259"/>
           </p14:sldIdLst>
         </p14:section>
-        <p14:section name="Solusi" id="{a8fed365-2822-87d1-cd1a-521626ca29e5}">
+        <p14:section name="Solusi" id="{688325e6-9302-e3eb-f31c-69d07ab98580}">
           <p14:sldIdLst>
             <p14:sldId id="260"/>
             <p14:sldId id="261"/>
             <p14:sldId id="262"/>
           </p14:sldIdLst>
         </p14:section>
-        <p14:section name="Teknis &amp; data" id="{6fd79dfb-5d64-97fa-1d5d-6b1682e7d759}">
+        <p14:section name="Teknis &amp; data" id="{ee83d627-9761-a797-3044-f2e02f7e7d40}">
           <p14:sldIdLst>
             <p14:sldId id="263"/>
             <p14:sldId id="264"/>
             <p14:sldId id="265"/>
           </p14:sldIdLst>
         </p14:section>
-        <p14:section name="Hasil" id="{8f11c081-4802-636a-8cdb-cee0f64152eb}">
+        <p14:section name="Hasil" id="{47605e3d-c689-442a-f049-0ff722d876e3}">
           <p14:sldIdLst>
             <p14:sldId id="266"/>
             <p14:sldId id="267"/>
             <p14:sldId id="268"/>
           </p14:sldIdLst>
         </p14:section>
-        <p14:section name="Rencana" id="{266b0b75-e79f-0722-55dd-c922a0e355f7}">
+        <p14:section name="Rencana" id="{aeafbdfc-e2b7-0cdb-9b0b-5e550a342ffa}">
           <p14:sldIdLst>
             <p14:sldId id="269"/>
             <p14:sldId id="270"/>
           </p14:sldIdLst>
         </p14:section>
-        <p14:section name="Dampak" id="{abd87249-df72-7a6a-2138-fc6049af9460}">
+        <p14:section name="Dampak" id="{8e9b2d13-e1a2-93c9-3065-2f21194e7ec5}">
           <p14:sldIdLst>
             <p14:sldId id="271"/>
             <p14:sldId id="272"/>
             <p14:sldId id="273"/>
           </p14:sldIdLst>
         </p14:section>
-        <p14:section name="Tim &amp; penutup" id="{64d5e1c4-1a28-4aef-e4af-e55ecfbe3cba}">
+        <p14:section name="Tim &amp; penutup" id="{1c2f6ec8-13a1-92f8-d674-d50b3923b897}">
           <p14:sldIdLst>
             <p14:sldId id="274"/>
             <p14:sldId id="275"/>
@@ -313,10 +313,10 @@
                 <c:ptCount val="3"/>
                 <c:lvl>
                   <c:pt idx="0">
-                    <c:v>Pilih acak</c:v>
+                    <c:v>Random</c:v>
                   </c:pt>
                   <c:pt idx="1">
-                    <c:v>Aturan tunggal terbaik</c:v>
+                    <c:v>Best single rule</c:v>
                   </c:pt>
                   <c:pt idx="2">
                     <c:v>PayRay</c:v>
@@ -595,7 +595,7 @@
                 <c:ptCount val="2"/>
                 <c:lvl>
                   <c:pt idx="0">
-                    <c:v>Pilih acak</c:v>
+                    <c:v>Random</c:v>
                   </c:pt>
                   <c:pt idx="1">
                     <c:v>PayRay</c:v>
@@ -1327,7 +1327,7 @@
           <a:p>
             <a:r>
               <a:rPr lang="en-US" dirty="0"/>
-              <a:t>Slide baru. Angka dari hasil_holdout/laporan_akurasi.md (seed dunia 2026, seed injeksi berbeda). Aturan tunggal terbaik = rasio pekerja vs OSS (53,8%). Data dev: 69,4% / 4,63×. Akui kelemahan bila ditanya: recall modus sulit 18–37%, salah tandai menengah/besar ±6%.</a:t>
+              <a:t>Slide baru. Angka dari hasil_holdout/laporan_akurasi.md (seed dunia 2026, seed injeksi berbeda). Best single rule = rasio pekerja vs OSS (53,8%). Data dev: 69,4% / 4,63×. Akui kelemahan bila ditanya: recall modus sulit 18–37%, salah tandai menengah/besar ±6%.</a:t>
             </a:r>
             <a:endParaRPr lang="en-US" dirty="0"/>
           </a:p>
@@ -1415,7 +1415,7 @@
           <a:p>
             <a:r>
               <a:rPr lang="en-US" dirty="0"/>
-              <a:t>Tangkapan layar asli dari dashboard/index.html (HTML statis, dibangun dari output mesin; buka langsung di browser). Tombol Tandai wajar / Temuan terbukti menyimpan label umpan balik dan bisa diunduh sebagai CSV. Siklus umpan balik disimulasikan di engine/feedback.py: precision putaran 2 naik 21,8% → 26,8%, iuran tertangkap Rp1,60 M → Rp1,81 M (holdout). Waktu menyusun daftar: 5.000 badan usaha diskor dalam hitungan detik.</a:t>
+              <a:t>Screenshot asli dari dashboard/index.html (HTML statis, dibangun dari output mesin; buka langsung di browser). Tombol Tandai wajar / Temuan terbukti menyimpan label feedback dan bisa diunduh sebagai CSV. Feedback loop disimulasikan di engine/feedback.py: precision putaran 2 naik 21,8% → 26,8%, iuran tertangkap Rp1,60 M → Rp1,81 M (holdout). Waktu menyusun daftar: 5.000 badan usaha diskor dalam hitungan detik.</a:t>
             </a:r>
             <a:endParaRPr lang="en-US" dirty="0"/>
           </a:p>
@@ -1767,7 +1767,7 @@
           <a:p>
             <a:r>
               <a:rPr lang="en-US" dirty="0"/>
-              <a:t>Revisi: placeholder terisi. Precision 68,4% sedikit di bawah target 70%. Sampaikan jujur: target ≥70% dikejar lewat siklus umpan balik.</a:t>
+              <a:t>Revisi: placeholder terisi. Precision 68,4% sedikit di bawah target 70%. Sampaikan jujur: target ≥70% dikejar lewat feedback loop.</a:t>
             </a:r>
             <a:endParaRPr lang="en-US" dirty="0"/>
           </a:p>
@@ -4595,7 +4595,7 @@
                 <a:ea typeface="Montserrat" pitchFamily="34" charset="-122"/>
                 <a:cs typeface="Montserrat" pitchFamily="34" charset="-120"/>
               </a:rPr>
-              <a:t>Dunia jujur</a:t>
+              <a:t>Ground truth</a:t>
             </a:r>
             <a:endParaRPr lang="en-US" sz="1800" dirty="0"/>
           </a:p>
@@ -4780,7 +4780,7 @@
                 <a:ea typeface="Montserrat" pitchFamily="34" charset="-122"/>
                 <a:cs typeface="Montserrat" pitchFamily="34" charset="-120"/>
               </a:rPr>
-              <a:t>Penyisipan blind</a:t>
+              <a:t>Blind injection</a:t>
             </a:r>
             <a:endParaRPr lang="en-US" sz="1800" dirty="0"/>
           </a:p>
@@ -4816,7 +4816,7 @@
                   <a:schemeClr val="accent5"/>
                 </a:solidFill>
               </a:rPr>
-              <a:t>15% pelanggar, seed rahasia, kasus mudah &amp; sulit, 1–2 modus</a:t>
+              <a:t>15% pelanggar, seed rahasia, easy &amp; hard case, 1–2 modus</a:t>
             </a:r>
             <a:endParaRPr lang="en-US" sz="1400" dirty="0"/>
           </a:p>
@@ -5150,7 +5150,7 @@
                 <a:ea typeface="Montserrat" pitchFamily="34" charset="-122"/>
                 <a:cs typeface="Montserrat" pitchFamily="34" charset="-120"/>
               </a:rPr>
-              <a:t>Uji di data baru</a:t>
+              <a:t>Holdout test</a:t>
             </a:r>
             <a:endParaRPr lang="en-US" sz="1800" dirty="0"/>
           </a:p>
@@ -5186,7 +5186,7 @@
                   <a:schemeClr val="accent5"/>
                 </a:solidFill>
               </a:rPr>
-              <a:t>Mesin dinilai pada dataset holdout yang tidak pernah dilihat saat penyetelan</a:t>
+              <a:t>Mesin dinilai pada dataset holdout yang tidak pernah dilihat saat tuning</a:t>
             </a:r>
             <a:endParaRPr lang="en-US" sz="1400" dirty="0"/>
           </a:p>
@@ -5244,7 +5244,7 @@
                   <a:schemeClr val="accent1"/>
                 </a:solidFill>
               </a:rPr>
-              <a:t>Kebocoran label: metadata AUC ≈ 0,5</a:t>
+              <a:t>Label leakage: AUC ≈ 0,5</a:t>
             </a:r>
             <a:endParaRPr lang="en-US" sz="1400" dirty="0"/>
           </a:p>
@@ -5418,7 +5418,7 @@
                   <a:schemeClr val="accent1"/>
                 </a:solidFill>
               </a:rPr>
-              <a:t>Precision dilaporkan terpisah: mudah vs sulit</a:t>
+              <a:t>Precision terpisah: easy vs hard case</a:t>
             </a:r>
             <a:endParaRPr lang="en-US" sz="1400" dirty="0"/>
           </a:p>
@@ -5917,7 +5917,7 @@
                   <a:schemeClr val="accent5"/>
                 </a:solidFill>
               </a:rPr>
-              <a:t>Data simulasi holdout (5.000 badan usaha, tidak pernah dilihat saat penyetelan). Mesin aturan + Isolation Forest menilai tanpa label.</a:t>
+              <a:t>Data simulasi holdout (5.000 badan usaha, tidak pernah dilihat saat tuning). Mesin aturan + Isolation Forest menilai tanpa label.</a:t>
             </a:r>
             <a:endParaRPr lang="en-US" sz="1200" dirty="0"/>
           </a:p>
@@ -6104,7 +6104,7 @@
       </p:sp>
       <p:pic>
         <p:nvPicPr>
-          <p:cNvPr id="5" name="tangkapan-dashboard" descr="Tangkapan layar dashboard PayRay: antrean pemeriksaan dan lembar hasil scan PT Cahaya Mandiri">    </p:cNvPr>
+          <p:cNvPr id="5" name="tangkapan-dashboard" descr="Screenshot dashboard PayRay: antrean pemeriksaan dan lembar hasil scan PT Cahaya Mandiri">    </p:cNvPr>
           <p:cNvPicPr>
             <a:picLocks noChangeAspect="1"/>
           </p:cNvPicPr>
@@ -6156,7 +6156,7 @@
                   <a:schemeClr val="accent5"/>
                 </a:solidFill>
               </a:rPr>
-              <a:t>Tangkapan layar asli prototype dashboard (data sintetis)</a:t>
+              <a:t>Screenshot asli prototype dashboard (data sintetis)</a:t>
             </a:r>
             <a:endParaRPr lang="en-US" sz="1200" dirty="0"/>
           </a:p>
@@ -10668,7 +10668,7 @@
                   <a:schemeClr val="tx1"/>
                 </a:solidFill>
               </a:rPr>
-              <a:t>Model diperbarui dari umpan balik</a:t>
+              <a:t>Model diperbarui dari feedback</a:t>
             </a:r>
             <a:endParaRPr lang="en-US" sz="1500" dirty="0"/>
           </a:p>
@@ -14482,7 +14482,7 @@
                   <a:schemeClr val="tx1"/>
                 </a:solidFill>
               </a:rPr>
-              <a:t>Model usang → retrain berkala dari umpan balik</a:t>
+              <a:t>Model usang → retrain berkala dari feedback</a:t>
             </a:r>
             <a:endParaRPr lang="en-US" sz="1400" dirty="0"/>
           </a:p>

</xml_diff>

<commit_message>
Aktifkan GitHub Pages: redirect root ke dashboard, isi link demo di deck
Co-Authored-By: Claude Opus 5.5 <noreply@anthropic.com>
</commit_message>
<xml_diff>
--- a/docs/deck/PayRay_Healthkathon2026_revisi.pptx
+++ b/docs/deck/PayRay_Healthkathon2026_revisi.pptx
@@ -126,53 +126,53 @@
   <p:extLst>
     <p:ext uri="{521415D9-36F7-43E2-AB2F-B90AF26B5E84}">
       <p14:sectionLst xmlns:p14="http://schemas.microsoft.com/office/powerpoint/2010/main">
-        <p14:section name="Pembuka" id="{c660a211-5ae8-4ee9-73b5-03485162d572}">
+        <p14:section name="Pembuka" id="{9dfea75e-0e21-f119-1c2a-a8a2677e10dd}">
           <p14:sldIdLst>
             <p14:sldId id="256"/>
             <p14:sldId id="257"/>
           </p14:sldIdLst>
         </p14:section>
-        <p14:section name="Masalah" id="{6ab41160-dcda-2423-b02b-2c3609aeeacb}">
+        <p14:section name="Masalah" id="{c03498d5-d05c-3bb2-6a82-3b8b865644ff}">
           <p14:sldIdLst>
             <p14:sldId id="258"/>
             <p14:sldId id="259"/>
           </p14:sldIdLst>
         </p14:section>
-        <p14:section name="Solusi" id="{688325e6-9302-e3eb-f31c-69d07ab98580}">
+        <p14:section name="Solusi" id="{12ea8b31-361f-586d-629a-0a2489633588}">
           <p14:sldIdLst>
             <p14:sldId id="260"/>
             <p14:sldId id="261"/>
             <p14:sldId id="262"/>
           </p14:sldIdLst>
         </p14:section>
-        <p14:section name="Teknis &amp; data" id="{ee83d627-9761-a797-3044-f2e02f7e7d40}">
+        <p14:section name="Teknis &amp; data" id="{efaf1db6-5b15-5881-e89a-67f28c865ed6}">
           <p14:sldIdLst>
             <p14:sldId id="263"/>
             <p14:sldId id="264"/>
             <p14:sldId id="265"/>
           </p14:sldIdLst>
         </p14:section>
-        <p14:section name="Hasil" id="{47605e3d-c689-442a-f049-0ff722d876e3}">
+        <p14:section name="Hasil" id="{7c5b5715-2370-0fea-e067-f4214359c2bd}">
           <p14:sldIdLst>
             <p14:sldId id="266"/>
             <p14:sldId id="267"/>
             <p14:sldId id="268"/>
           </p14:sldIdLst>
         </p14:section>
-        <p14:section name="Rencana" id="{aeafbdfc-e2b7-0cdb-9b0b-5e550a342ffa}">
+        <p14:section name="Rencana" id="{bb255a9d-eff3-a8be-ad07-bc92e278a737}">
           <p14:sldIdLst>
             <p14:sldId id="269"/>
             <p14:sldId id="270"/>
           </p14:sldIdLst>
         </p14:section>
-        <p14:section name="Dampak" id="{8e9b2d13-e1a2-93c9-3065-2f21194e7ec5}">
+        <p14:section name="Dampak" id="{01176b3d-c2f7-4607-a73c-7b33ff419a3f}">
           <p14:sldIdLst>
             <p14:sldId id="271"/>
             <p14:sldId id="272"/>
             <p14:sldId id="273"/>
           </p14:sldIdLst>
         </p14:section>
-        <p14:section name="Tim &amp; penutup" id="{1c2f6ec8-13a1-92f8-d674-d50b3923b897}">
+        <p14:section name="Tim &amp; penutup" id="{1643b8d8-f673-2ae4-db20-2a54cbfc404a}">
           <p14:sldIdLst>
             <p14:sldId id="274"/>
             <p14:sldId id="275"/>
@@ -8042,7 +8042,7 @@
                   <a:schemeClr val="tx1"/>
                 </a:solidFill>
               </a:rPr>
-              <a:t>Link demo: [__]</a:t>
+              <a:t>Link demo: rachdiaan.github.io/healthkathon-bpjs</a:t>
             </a:r>
             <a:endParaRPr lang="en-US" sz="1500" dirty="0"/>
           </a:p>

</xml_diff>

<commit_message>
Lapisan ML: model monoton dari hasil pemeriksaan (IPW), stacking terkalibrasi, CQR Rp, data quality checks; model berjalan di browser
- ml/: training, validasi di world holdout (bootstrap CI, kalibrasi, learning curve, stabilitas, permutation importance, fairness, PSI)
- dashboard: tab Validasi model, Kualitas data, Metodologi; kapasitas pemeriksaan; bukti grafik, kontribusi fitur, what-if di lembar scan
- tests/test_ml.py: parity ekspor, aditivitas atribusi, monotonic constraint, deteksi data rusak

Co-Authored-By: Claude Opus 5.5 <noreply@anthropic.com>
</commit_message>
<xml_diff>
--- a/docs/deck/PayRay_Healthkathon2026_revisi.pptx
+++ b/docs/deck/PayRay_Healthkathon2026_revisi.pptx
@@ -126,53 +126,53 @@
   <p:extLst>
     <p:ext uri="{521415D9-36F7-43E2-AB2F-B90AF26B5E84}">
       <p14:sectionLst xmlns:p14="http://schemas.microsoft.com/office/powerpoint/2010/main">
-        <p14:section name="Pembuka" id="{9dfea75e-0e21-f119-1c2a-a8a2677e10dd}">
+        <p14:section name="Pembuka" id="{a617b40a-d2bd-868b-b901-06294000af17}">
           <p14:sldIdLst>
             <p14:sldId id="256"/>
             <p14:sldId id="257"/>
           </p14:sldIdLst>
         </p14:section>
-        <p14:section name="Masalah" id="{c03498d5-d05c-3bb2-6a82-3b8b865644ff}">
+        <p14:section name="Masalah" id="{12d03ad3-49d4-82fe-8412-4163b02eb711}">
           <p14:sldIdLst>
             <p14:sldId id="258"/>
             <p14:sldId id="259"/>
           </p14:sldIdLst>
         </p14:section>
-        <p14:section name="Solusi" id="{12ea8b31-361f-586d-629a-0a2489633588}">
+        <p14:section name="Solusi" id="{e420b1c1-01da-3706-e528-ebf422432d6b}">
           <p14:sldIdLst>
             <p14:sldId id="260"/>
             <p14:sldId id="261"/>
             <p14:sldId id="262"/>
           </p14:sldIdLst>
         </p14:section>
-        <p14:section name="Teknis &amp; data" id="{efaf1db6-5b15-5881-e89a-67f28c865ed6}">
+        <p14:section name="Teknis &amp; data" id="{3e037953-5812-a8a8-c98d-5ad5cdd4f43e}">
           <p14:sldIdLst>
             <p14:sldId id="263"/>
             <p14:sldId id="264"/>
             <p14:sldId id="265"/>
           </p14:sldIdLst>
         </p14:section>
-        <p14:section name="Hasil" id="{7c5b5715-2370-0fea-e067-f4214359c2bd}">
+        <p14:section name="Hasil" id="{16a64f76-3866-50e1-3d48-5faea1b068fd}">
           <p14:sldIdLst>
             <p14:sldId id="266"/>
             <p14:sldId id="267"/>
             <p14:sldId id="268"/>
           </p14:sldIdLst>
         </p14:section>
-        <p14:section name="Rencana" id="{bb255a9d-eff3-a8be-ad07-bc92e278a737}">
+        <p14:section name="Rencana" id="{8f356064-e1ac-851a-17d0-3296fa471180}">
           <p14:sldIdLst>
             <p14:sldId id="269"/>
             <p14:sldId id="270"/>
           </p14:sldIdLst>
         </p14:section>
-        <p14:section name="Dampak" id="{01176b3d-c2f7-4607-a73c-7b33ff419a3f}">
+        <p14:section name="Dampak" id="{4d8ac6a7-436b-d329-a959-fb77881601e7}">
           <p14:sldIdLst>
             <p14:sldId id="271"/>
             <p14:sldId id="272"/>
             <p14:sldId id="273"/>
           </p14:sldIdLst>
         </p14:section>
-        <p14:section name="Tim &amp; penutup" id="{1643b8d8-f673-2ae4-db20-2a54cbfc404a}">
+        <p14:section name="Tim &amp; penutup" id="{c3a933b1-2285-2a83-ee49-ab44d92eb45f}">
           <p14:sldIdLst>
             <p14:sldId id="274"/>
             <p14:sldId id="275"/>

</xml_diff>